<commit_message>
updated the presentation with some results from the model.
</commit_message>
<xml_diff>
--- a/presentations/project1_presentation.pptx
+++ b/presentations/project1_presentation.pptx
@@ -6,7 +6,7 @@
     <p:sldMasterId id="2147483652" r:id="rId2"/>
   </p:sldMasterIdLst>
   <p:notesMasterIdLst>
-    <p:notesMasterId r:id="rId19"/>
+    <p:notesMasterId r:id="rId21"/>
   </p:notesMasterIdLst>
   <p:sldIdLst>
     <p:sldId id="256" r:id="rId3"/>
@@ -19,12 +19,14 @@
     <p:sldId id="263" r:id="rId10"/>
     <p:sldId id="264" r:id="rId11"/>
     <p:sldId id="265" r:id="rId12"/>
-    <p:sldId id="266" r:id="rId13"/>
-    <p:sldId id="267" r:id="rId14"/>
-    <p:sldId id="268" r:id="rId15"/>
-    <p:sldId id="269" r:id="rId16"/>
-    <p:sldId id="270" r:id="rId17"/>
-    <p:sldId id="271" r:id="rId18"/>
+    <p:sldId id="272" r:id="rId13"/>
+    <p:sldId id="273" r:id="rId14"/>
+    <p:sldId id="274" r:id="rId15"/>
+    <p:sldId id="267" r:id="rId16"/>
+    <p:sldId id="268" r:id="rId17"/>
+    <p:sldId id="269" r:id="rId18"/>
+    <p:sldId id="270" r:id="rId19"/>
+    <p:sldId id="271" r:id="rId20"/>
   </p:sldIdLst>
   <p:sldSz cx="10080625" cy="5670550"/>
   <p:notesSz cx="7772400" cy="10058400"/>
@@ -123,6 +125,11 @@
       </a:defRPr>
     </a:lvl9pPr>
   </p:defaultTextStyle>
+  <p:extLst>
+    <p:ext uri="{EFAFB233-063F-42B5-8137-9DF3F51BA10A}">
+      <p15:sldGuideLst xmlns:p15="http://schemas.microsoft.com/office/powerpoint/2012/main"/>
+    </p:ext>
+  </p:extLst>
 </p:presentation>
 </file>
 
@@ -5660,7 +5667,7 @@
 </file>
 
 <file path=ppt/slides/slide11.xml><?xml version="1.0" encoding="utf-8"?>
-<p:sld xmlns:a="http://schemas.openxmlformats.org/drawingml/2006/main" xmlns:r="http://schemas.openxmlformats.org/officeDocument/2006/relationships" xmlns:p="http://schemas.openxmlformats.org/presentationml/2006/main" show="0">
+<p:sld xmlns:a="http://schemas.openxmlformats.org/drawingml/2006/main" xmlns:r="http://schemas.openxmlformats.org/officeDocument/2006/relationships" xmlns:p="http://schemas.openxmlformats.org/presentationml/2006/main">
   <p:cSld>
     <p:spTree>
       <p:nvGrpSpPr>
@@ -5678,7 +5685,13 @@
       </p:grpSpPr>
       <p:sp>
         <p:nvSpPr>
-          <p:cNvPr id="59" name="PlaceHolder 1"/>
+          <p:cNvPr id="2" name="Title 1">
+            <a:extLst>
+              <a:ext uri="{FF2B5EF4-FFF2-40B4-BE49-F238E27FC236}">
+                <a16:creationId xmlns:a16="http://schemas.microsoft.com/office/drawing/2014/main" id="{59EA342C-93DB-9052-E162-1773898CB748}"/>
+              </a:ext>
+            </a:extLst>
+          </p:cNvPr>
           <p:cNvSpPr>
             <a:spLocks noGrp="1"/>
           </p:cNvSpPr>
@@ -5688,58 +5701,34 @@
         </p:nvSpPr>
         <p:spPr>
           <a:xfrm>
-            <a:off x="504000" y="394560"/>
-            <a:ext cx="9071280" cy="609120"/>
+            <a:off x="539952" y="526396"/>
+            <a:ext cx="9000720" cy="429348"/>
           </a:xfrm>
-          <a:prstGeom prst="rect">
-            <a:avLst/>
-          </a:prstGeom>
-          <a:noFill/>
-          <a:ln w="0">
-            <a:noFill/>
-          </a:ln>
         </p:spPr>
         <p:txBody>
-          <a:bodyPr lIns="0" tIns="0" rIns="0" bIns="0" anchor="ctr">
-            <a:noAutofit/>
-          </a:bodyPr>
+          <a:bodyPr/>
           <a:lstStyle/>
           <a:p>
-            <a:pPr indent="0" algn="ctr" defTabSz="914400">
-              <a:lnSpc>
-                <a:spcPct val="90000"/>
-              </a:lnSpc>
-              <a:buNone/>
-              <a:tabLst>
-                <a:tab pos="0" algn="l"/>
-              </a:tabLst>
-            </a:pPr>
-            <a:r>
-              <a:rPr lang="en-US" sz="4400" b="0" u="none" strike="noStrike">
-                <a:solidFill>
-                  <a:srgbClr val="000000"/>
-                </a:solidFill>
-                <a:effectLst/>
-                <a:uFillTx/>
-                <a:latin typeface="Arial"/>
-                <a:ea typeface="DejaVu Sans"/>
-              </a:rPr>
-              <a:t>Conclusion</a:t>
-            </a:r>
-            <a:endParaRPr lang="en-US" sz="4400" b="0" u="none" strike="noStrike">
-              <a:solidFill>
-                <a:srgbClr val="DD4100"/>
-              </a:solidFill>
-              <a:effectLst/>
-              <a:uFillTx/>
-              <a:latin typeface="Times New Roman"/>
-            </a:endParaRPr>
+            <a:r>
+              <a:rPr lang="en-US" dirty="0">
+                <a:solidFill>
+                  <a:schemeClr val="tx1"/>
+                </a:solidFill>
+              </a:rPr>
+              <a:t>Example model output</a:t>
+            </a:r>
           </a:p>
         </p:txBody>
       </p:sp>
       <p:sp>
         <p:nvSpPr>
-          <p:cNvPr id="60" name="PlaceHolder 2"/>
+          <p:cNvPr id="3" name="Subtitle 2">
+            <a:extLst>
+              <a:ext uri="{FF2B5EF4-FFF2-40B4-BE49-F238E27FC236}">
+                <a16:creationId xmlns:a16="http://schemas.microsoft.com/office/drawing/2014/main" id="{E62BD978-E37A-FAC0-3288-B9B90DD8090C}"/>
+              </a:ext>
+            </a:extLst>
+          </p:cNvPr>
           <p:cNvSpPr>
             <a:spLocks noGrp="1"/>
           </p:cNvSpPr>
@@ -5749,259 +5738,131 @@
         </p:nvSpPr>
         <p:spPr>
           <a:xfrm>
-            <a:off x="504000" y="1066680"/>
-            <a:ext cx="9071280" cy="4138200"/>
+            <a:off x="360000" y="955744"/>
+            <a:ext cx="9360720" cy="4879339"/>
           </a:xfrm>
-          <a:prstGeom prst="rect">
-            <a:avLst/>
-          </a:prstGeom>
-          <a:noFill/>
-          <a:ln w="0">
-            <a:noFill/>
-          </a:ln>
         </p:spPr>
         <p:txBody>
-          <a:bodyPr lIns="0" tIns="0" rIns="0" bIns="0" anchor="ctr">
-            <a:noAutofit/>
-          </a:bodyPr>
+          <a:bodyPr/>
           <a:lstStyle/>
           <a:p>
-            <a:pPr marL="228600" indent="-228600" algn="l" defTabSz="914400">
-              <a:lnSpc>
-                <a:spcPct val="90000"/>
-              </a:lnSpc>
-              <a:spcBef>
-                <a:spcPts val="1417"/>
-              </a:spcBef>
-              <a:buClr>
-                <a:srgbClr val="000000"/>
-              </a:buClr>
-              <a:buSzPct val="45000"/>
-              <a:buFont typeface="Wingdings" charset="2"/>
-              <a:buChar char=""/>
-            </a:pPr>
-            <a:r>
-              <a:rPr lang="en-US" sz="1800" b="0" u="none" strike="noStrike">
-                <a:solidFill>
-                  <a:srgbClr val="000000"/>
-                </a:solidFill>
-                <a:effectLst/>
-                <a:uFillTx/>
-                <a:latin typeface="Arial"/>
-                <a:ea typeface="DejaVu Sans"/>
-              </a:rPr>
-              <a:t>Each additional 10,000 miles is associated with an average 2.2% decrease in selling price, holding all other variables constant.</a:t>
-            </a:r>
-            <a:endParaRPr lang="en-US" sz="1800" b="0" u="none" strike="noStrike">
-              <a:solidFill>
-                <a:srgbClr val="000000"/>
-              </a:solidFill>
-              <a:effectLst/>
-              <a:highlight>
-                <a:srgbClr val="FFFFFF"/>
-              </a:highlight>
-              <a:uFillTx/>
-              <a:latin typeface="Times New Roman"/>
-            </a:endParaRPr>
-          </a:p>
-          <a:p>
-            <a:pPr marL="228600" indent="-228600" algn="l" defTabSz="914400">
-              <a:lnSpc>
-                <a:spcPct val="90000"/>
-              </a:lnSpc>
-              <a:spcBef>
-                <a:spcPts val="1417"/>
-              </a:spcBef>
-              <a:buClr>
-                <a:srgbClr val="000000"/>
-              </a:buClr>
-              <a:buSzPct val="45000"/>
-              <a:buFont typeface="Wingdings" charset="2"/>
-              <a:buChar char=""/>
-            </a:pPr>
-            <a:r>
-              <a:rPr lang="en-US" sz="1800" b="0" u="none" strike="noStrike">
-                <a:solidFill>
-                  <a:srgbClr val="000000"/>
-                </a:solidFill>
-                <a:effectLst/>
-                <a:uFillTx/>
-                <a:latin typeface="Arial"/>
-                <a:ea typeface="DejaVu Sans"/>
-              </a:rPr>
-              <a:t>Each additional year of vehicle age is associated with an average 13.8% decrease in selling price, holding all other variables constant.</a:t>
-            </a:r>
-            <a:endParaRPr lang="en-US" sz="1800" b="0" u="none" strike="noStrike">
-              <a:solidFill>
-                <a:srgbClr val="000000"/>
-              </a:solidFill>
-              <a:effectLst/>
-              <a:highlight>
-                <a:srgbClr val="FFFFFF"/>
-              </a:highlight>
-              <a:uFillTx/>
-              <a:latin typeface="Times New Roman"/>
-            </a:endParaRPr>
-          </a:p>
-          <a:p>
-            <a:pPr marL="228600" indent="-228600" algn="l" defTabSz="914400">
-              <a:lnSpc>
-                <a:spcPct val="90000"/>
-              </a:lnSpc>
-              <a:spcBef>
-                <a:spcPts val="1417"/>
-              </a:spcBef>
-              <a:buClr>
-                <a:srgbClr val="000000"/>
-              </a:buClr>
-              <a:buSzPct val="45000"/>
-              <a:buFont typeface="Wingdings" charset="2"/>
-              <a:buChar char=""/>
-            </a:pPr>
-            <a:r>
-              <a:rPr lang="en-US" sz="1800" b="0" u="none" strike="noStrike">
-                <a:solidFill>
-                  <a:srgbClr val="000000"/>
-                </a:solidFill>
-                <a:effectLst/>
-                <a:uFillTx/>
-                <a:latin typeface="Arial"/>
-                <a:ea typeface="DejaVu Sans"/>
-              </a:rPr>
-              <a:t>A one-point increase in vehicle condition is associated with approximately a 2.0% increase in selling price, holding all other variables constant.</a:t>
-            </a:r>
-            <a:endParaRPr lang="en-US" sz="1800" b="0" u="none" strike="noStrike">
-              <a:solidFill>
-                <a:srgbClr val="000000"/>
-              </a:solidFill>
-              <a:effectLst/>
-              <a:highlight>
-                <a:srgbClr val="FFFFFF"/>
-              </a:highlight>
-              <a:uFillTx/>
-              <a:latin typeface="Times New Roman"/>
-            </a:endParaRPr>
-          </a:p>
-          <a:p>
-            <a:pPr marL="228600" indent="-228600" algn="l" defTabSz="914400">
-              <a:lnSpc>
-                <a:spcPct val="90000"/>
-              </a:lnSpc>
-              <a:spcBef>
-                <a:spcPts val="1417"/>
-              </a:spcBef>
-              <a:buClr>
-                <a:srgbClr val="000000"/>
-              </a:buClr>
-              <a:buSzPct val="45000"/>
-              <a:buFont typeface="Wingdings" charset="2"/>
-              <a:buChar char=""/>
-            </a:pPr>
-            <a:r>
-              <a:rPr lang="en-US" sz="1800" b="0" u="none" strike="noStrike">
-                <a:solidFill>
-                  <a:srgbClr val="000000"/>
-                </a:solidFill>
-                <a:effectLst/>
-                <a:uFillTx/>
-                <a:latin typeface="Arial"/>
-                <a:ea typeface="DejaVu Sans"/>
-              </a:rPr>
-              <a:t>Among the continuous vehicle characteristics (odometer, condition) analyzed, vehicle age has the strongest relationship with selling price</a:t>
-            </a:r>
-            <a:endParaRPr lang="en-US" sz="1800" b="0" u="none" strike="noStrike">
-              <a:solidFill>
-                <a:srgbClr val="000000"/>
-              </a:solidFill>
-              <a:effectLst/>
-              <a:highlight>
-                <a:srgbClr val="FFFFFF"/>
-              </a:highlight>
-              <a:uFillTx/>
-              <a:latin typeface="Times New Roman"/>
-            </a:endParaRPr>
-          </a:p>
-          <a:p>
-            <a:pPr marL="228600" indent="-228600" algn="l" defTabSz="914400">
-              <a:lnSpc>
-                <a:spcPct val="90000"/>
-              </a:lnSpc>
-              <a:spcBef>
-                <a:spcPts val="1417"/>
-              </a:spcBef>
-              <a:buClr>
-                <a:srgbClr val="000000"/>
-              </a:buClr>
-              <a:buSzPct val="45000"/>
-              <a:buFont typeface="Wingdings" charset="2"/>
-              <a:buChar char=""/>
-            </a:pPr>
-            <a:r>
-              <a:rPr lang="en-US" sz="1800" b="0" u="none" strike="noStrike">
-                <a:solidFill>
-                  <a:srgbClr val="000000"/>
-                </a:solidFill>
-                <a:effectLst/>
-                <a:uFillTx/>
-                <a:latin typeface="Arial"/>
-                <a:ea typeface="DejaVu Sans"/>
-              </a:rPr>
-              <a:t>Vehicle model captures differences in vehicle type, original MSRP, market demand, towing capability, luxury features, and brand perception that are not explained by age, mileage, or condition alone.</a:t>
-            </a:r>
-            <a:endParaRPr lang="en-US" sz="1800" b="0" u="none" strike="noStrike">
-              <a:solidFill>
-                <a:srgbClr val="000000"/>
-              </a:solidFill>
-              <a:effectLst/>
-              <a:highlight>
-                <a:srgbClr val="FFFFFF"/>
-              </a:highlight>
-              <a:uFillTx/>
-              <a:latin typeface="Times New Roman"/>
-            </a:endParaRPr>
-          </a:p>
-          <a:p>
-            <a:pPr marL="228600" indent="-228600" algn="l" defTabSz="914400">
-              <a:lnSpc>
-                <a:spcPct val="90000"/>
-              </a:lnSpc>
-              <a:spcBef>
-                <a:spcPts val="1417"/>
-              </a:spcBef>
-              <a:buClr>
-                <a:srgbClr val="000000"/>
-              </a:buClr>
-              <a:buSzPct val="45000"/>
-              <a:buFont typeface="Wingdings" charset="2"/>
-              <a:buChar char=""/>
-            </a:pPr>
-            <a:r>
-              <a:rPr lang="en-US" sz="1800" b="0" u="none" strike="noStrike">
-                <a:solidFill>
-                  <a:srgbClr val="000000"/>
-                </a:solidFill>
-                <a:effectLst/>
-                <a:uFillTx/>
-                <a:latin typeface="Arial"/>
-                <a:ea typeface="DejaVu Sans"/>
-              </a:rPr>
-              <a:t>Heavy-duty pickup trucks consistently exhibited the highest estimated market values after controlling for age, mileage, condition, and transmission type.</a:t>
-            </a:r>
-            <a:endParaRPr lang="en-US" sz="1800" b="0" u="none" strike="noStrike">
-              <a:solidFill>
-                <a:srgbClr val="000000"/>
-              </a:solidFill>
-              <a:effectLst/>
-              <a:highlight>
-                <a:srgbClr val="FFFFFF"/>
-              </a:highlight>
-              <a:uFillTx/>
-              <a:latin typeface="Times New Roman"/>
-            </a:endParaRPr>
+            <a:r>
+              <a:rPr lang="en-US" sz="2000" dirty="0">
+                <a:solidFill>
+                  <a:schemeClr val="tx1"/>
+                </a:solidFill>
+              </a:rPr>
+              <a:t>=== Vehicle Valuation Prediction ===</a:t>
+            </a:r>
+          </a:p>
+          <a:p>
+            <a:r>
+              <a:rPr lang="en-US" sz="2000" dirty="0">
+                <a:solidFill>
+                  <a:schemeClr val="tx1"/>
+                </a:solidFill>
+              </a:rPr>
+              <a:t>Input Vehicle: Ram 1500</a:t>
+            </a:r>
+          </a:p>
+          <a:p>
+            <a:r>
+              <a:rPr lang="en-US" sz="2000" dirty="0">
+                <a:solidFill>
+                  <a:schemeClr val="tx1"/>
+                </a:solidFill>
+              </a:rPr>
+              <a:t>State: UT | Age: 7.0 years | Odometer: 115,000.0 miles | Condition: 30.0</a:t>
+            </a:r>
+          </a:p>
+          <a:p>
+            <a:r>
+              <a:rPr lang="en-US" sz="2000" dirty="0">
+                <a:solidFill>
+                  <a:schemeClr val="tx1"/>
+                </a:solidFill>
+              </a:rPr>
+              <a:t>Canonical Model Representation: 1500</a:t>
+            </a:r>
+          </a:p>
+          <a:p>
+            <a:r>
+              <a:rPr lang="en-US" sz="2000" dirty="0">
+                <a:solidFill>
+                  <a:schemeClr val="tx1"/>
+                </a:solidFill>
+              </a:rPr>
+              <a:t>------------------------------------</a:t>
+            </a:r>
+          </a:p>
+          <a:p>
+            <a:r>
+              <a:rPr lang="en-US" sz="2000" dirty="0">
+                <a:solidFill>
+                  <a:schemeClr val="tx1"/>
+                </a:solidFill>
+              </a:rPr>
+              <a:t>Predicted Log Selling Price:     9.1918</a:t>
+            </a:r>
+          </a:p>
+          <a:p>
+            <a:r>
+              <a:rPr lang="en-US" sz="2000" dirty="0">
+                <a:solidFill>
+                  <a:schemeClr val="tx1"/>
+                </a:solidFill>
+              </a:rPr>
+              <a:t>Predicted Median Value (naive):  $9,815.95</a:t>
+            </a:r>
+          </a:p>
+          <a:p>
+            <a:r>
+              <a:rPr lang="en-US" sz="2000" dirty="0">
+                <a:solidFill>
+                  <a:schemeClr val="tx1"/>
+                </a:solidFill>
+              </a:rPr>
+              <a:t>Predicted Expected Value (mean): $11,028.72</a:t>
+            </a:r>
+          </a:p>
+          <a:p>
+            <a:r>
+              <a:rPr lang="en-US" sz="2000" dirty="0">
+                <a:solidFill>
+                  <a:schemeClr val="tx1"/>
+                </a:solidFill>
+              </a:rPr>
+              <a:t>Predicted for sale in: UT</a:t>
+            </a:r>
+          </a:p>
+          <a:p>
+            <a:r>
+              <a:rPr lang="en-US" sz="2000" dirty="0">
+                <a:solidFill>
+                  <a:schemeClr val="tx1"/>
+                </a:solidFill>
+              </a:rPr>
+              <a:t>Trade-in offer for 10-15% profit: $9,374.41 to $9,925.85</a:t>
+            </a:r>
+          </a:p>
+          <a:p>
+            <a:r>
+              <a:rPr lang="en-US" sz="2000" dirty="0">
+                <a:solidFill>
+                  <a:schemeClr val="tx1"/>
+                </a:solidFill>
+              </a:rPr>
+              <a:t>====================================</a:t>
+            </a:r>
           </a:p>
         </p:txBody>
       </p:sp>
     </p:spTree>
+    <p:extLst>
+      <p:ext uri="{BB962C8B-B14F-4D97-AF65-F5344CB8AC3E}">
+        <p14:creationId xmlns:p14="http://schemas.microsoft.com/office/powerpoint/2010/main" val="2444242102"/>
+      </p:ext>
+    </p:extLst>
   </p:cSld>
   <p:clrMapOvr>
     <a:masterClrMapping/>
@@ -6010,6 +5871,427 @@
 </file>
 
 <file path=ppt/slides/slide12.xml><?xml version="1.0" encoding="utf-8"?>
+<p:sld xmlns:a="http://schemas.openxmlformats.org/drawingml/2006/main" xmlns:r="http://schemas.openxmlformats.org/officeDocument/2006/relationships" xmlns:p="http://schemas.openxmlformats.org/presentationml/2006/main">
+  <p:cSld>
+    <p:spTree>
+      <p:nvGrpSpPr>
+        <p:cNvPr id="1" name=""/>
+        <p:cNvGrpSpPr/>
+        <p:nvPr/>
+      </p:nvGrpSpPr>
+      <p:grpSpPr>
+        <a:xfrm>
+          <a:off x="0" y="0"/>
+          <a:ext cx="0" cy="0"/>
+          <a:chOff x="0" y="0"/>
+          <a:chExt cx="0" cy="0"/>
+        </a:xfrm>
+      </p:grpSpPr>
+      <p:sp>
+        <p:nvSpPr>
+          <p:cNvPr id="2" name="Title 1">
+            <a:extLst>
+              <a:ext uri="{FF2B5EF4-FFF2-40B4-BE49-F238E27FC236}">
+                <a16:creationId xmlns:a16="http://schemas.microsoft.com/office/drawing/2014/main" id="{4579430D-9979-6648-13F6-6C0E1E592274}"/>
+              </a:ext>
+            </a:extLst>
+          </p:cNvPr>
+          <p:cNvSpPr>
+            <a:spLocks noGrp="1"/>
+          </p:cNvSpPr>
+          <p:nvPr>
+            <p:ph type="title"/>
+          </p:nvPr>
+        </p:nvSpPr>
+        <p:spPr>
+          <a:xfrm>
+            <a:off x="539952" y="526396"/>
+            <a:ext cx="9000720" cy="429348"/>
+          </a:xfrm>
+        </p:spPr>
+        <p:txBody>
+          <a:bodyPr/>
+          <a:lstStyle/>
+          <a:p>
+            <a:r>
+              <a:rPr lang="en-US" dirty="0">
+                <a:solidFill>
+                  <a:schemeClr val="tx1"/>
+                </a:solidFill>
+              </a:rPr>
+              <a:t>Another model example</a:t>
+            </a:r>
+          </a:p>
+        </p:txBody>
+      </p:sp>
+      <p:sp>
+        <p:nvSpPr>
+          <p:cNvPr id="3" name="Subtitle 2">
+            <a:extLst>
+              <a:ext uri="{FF2B5EF4-FFF2-40B4-BE49-F238E27FC236}">
+                <a16:creationId xmlns:a16="http://schemas.microsoft.com/office/drawing/2014/main" id="{90148188-2394-30E5-B76C-E76821736CCD}"/>
+              </a:ext>
+            </a:extLst>
+          </p:cNvPr>
+          <p:cNvSpPr>
+            <a:spLocks noGrp="1"/>
+          </p:cNvSpPr>
+          <p:nvPr>
+            <p:ph type="subTitle"/>
+          </p:nvPr>
+        </p:nvSpPr>
+        <p:spPr>
+          <a:xfrm>
+            <a:off x="359952" y="1083644"/>
+            <a:ext cx="8568895" cy="4457631"/>
+          </a:xfrm>
+        </p:spPr>
+        <p:txBody>
+          <a:bodyPr/>
+          <a:lstStyle/>
+          <a:p>
+            <a:r>
+              <a:rPr lang="en-US" sz="2000" dirty="0">
+                <a:solidFill>
+                  <a:schemeClr val="tx1"/>
+                </a:solidFill>
+              </a:rPr>
+              <a:t>=== Vehicle Valuation Prediction ===</a:t>
+            </a:r>
+          </a:p>
+          <a:p>
+            <a:r>
+              <a:rPr lang="en-US" sz="2000" dirty="0">
+                <a:solidFill>
+                  <a:schemeClr val="tx1"/>
+                </a:solidFill>
+              </a:rPr>
+              <a:t>Input Vehicle: Honda Accord</a:t>
+            </a:r>
+          </a:p>
+          <a:p>
+            <a:r>
+              <a:rPr lang="en-US" sz="2000" dirty="0">
+                <a:solidFill>
+                  <a:schemeClr val="tx1"/>
+                </a:solidFill>
+              </a:rPr>
+              <a:t>State: UT | Age: 3.0 years | Odometer: 65,000.0 miles | Condition: 40.0</a:t>
+            </a:r>
+          </a:p>
+          <a:p>
+            <a:r>
+              <a:rPr lang="en-US" sz="2000" dirty="0">
+                <a:solidFill>
+                  <a:schemeClr val="tx1"/>
+                </a:solidFill>
+              </a:rPr>
+              <a:t>Canonical Model Representation: Accord</a:t>
+            </a:r>
+          </a:p>
+          <a:p>
+            <a:r>
+              <a:rPr lang="en-US" sz="2000" dirty="0">
+                <a:solidFill>
+                  <a:schemeClr val="tx1"/>
+                </a:solidFill>
+              </a:rPr>
+              <a:t>------------------------------------</a:t>
+            </a:r>
+          </a:p>
+          <a:p>
+            <a:r>
+              <a:rPr lang="en-US" sz="2000" dirty="0">
+                <a:solidFill>
+                  <a:schemeClr val="tx1"/>
+                </a:solidFill>
+              </a:rPr>
+              <a:t>Predicted Log Selling Price:     9.5440</a:t>
+            </a:r>
+          </a:p>
+          <a:p>
+            <a:r>
+              <a:rPr lang="en-US" sz="2000" dirty="0">
+                <a:solidFill>
+                  <a:schemeClr val="tx1"/>
+                </a:solidFill>
+              </a:rPr>
+              <a:t>Predicted Median Value (naive):  $13,961.09</a:t>
+            </a:r>
+          </a:p>
+          <a:p>
+            <a:r>
+              <a:rPr lang="en-US" sz="2000" dirty="0">
+                <a:solidFill>
+                  <a:schemeClr val="tx1"/>
+                </a:solidFill>
+              </a:rPr>
+              <a:t>Predicted Expected Value (mean): $15,685.99</a:t>
+            </a:r>
+          </a:p>
+          <a:p>
+            <a:r>
+              <a:rPr lang="en-US" sz="2000" dirty="0">
+                <a:solidFill>
+                  <a:schemeClr val="tx1"/>
+                </a:solidFill>
+              </a:rPr>
+              <a:t>Predicted for sale in: UT</a:t>
+            </a:r>
+          </a:p>
+          <a:p>
+            <a:r>
+              <a:rPr lang="en-US" sz="2000" dirty="0">
+                <a:solidFill>
+                  <a:schemeClr val="tx1"/>
+                </a:solidFill>
+              </a:rPr>
+              <a:t>Trade-in offer for 10-15% profit: $13,333.09 to $14,117.39</a:t>
+            </a:r>
+          </a:p>
+          <a:p>
+            <a:r>
+              <a:rPr lang="en-US" sz="2000" dirty="0">
+                <a:solidFill>
+                  <a:schemeClr val="tx1"/>
+                </a:solidFill>
+              </a:rPr>
+              <a:t>====================================</a:t>
+            </a:r>
+          </a:p>
+        </p:txBody>
+      </p:sp>
+    </p:spTree>
+    <p:extLst>
+      <p:ext uri="{BB962C8B-B14F-4D97-AF65-F5344CB8AC3E}">
+        <p14:creationId xmlns:p14="http://schemas.microsoft.com/office/powerpoint/2010/main" val="3157672830"/>
+      </p:ext>
+    </p:extLst>
+  </p:cSld>
+  <p:clrMapOvr>
+    <a:masterClrMapping/>
+  </p:clrMapOvr>
+</p:sld>
+</file>
+
+<file path=ppt/slides/slide13.xml><?xml version="1.0" encoding="utf-8"?>
+<p:sld xmlns:a="http://schemas.openxmlformats.org/drawingml/2006/main" xmlns:r="http://schemas.openxmlformats.org/officeDocument/2006/relationships" xmlns:p="http://schemas.openxmlformats.org/presentationml/2006/main">
+  <p:cSld>
+    <p:spTree>
+      <p:nvGrpSpPr>
+        <p:cNvPr id="1" name=""/>
+        <p:cNvGrpSpPr/>
+        <p:nvPr/>
+      </p:nvGrpSpPr>
+      <p:grpSpPr>
+        <a:xfrm>
+          <a:off x="0" y="0"/>
+          <a:ext cx="0" cy="0"/>
+          <a:chOff x="0" y="0"/>
+          <a:chExt cx="0" cy="0"/>
+        </a:xfrm>
+      </p:grpSpPr>
+      <p:sp>
+        <p:nvSpPr>
+          <p:cNvPr id="2" name="Title 1">
+            <a:extLst>
+              <a:ext uri="{FF2B5EF4-FFF2-40B4-BE49-F238E27FC236}">
+                <a16:creationId xmlns:a16="http://schemas.microsoft.com/office/drawing/2014/main" id="{AF208AD5-45B2-8CEC-3E8B-D3D9FC9187B2}"/>
+              </a:ext>
+            </a:extLst>
+          </p:cNvPr>
+          <p:cNvSpPr>
+            <a:spLocks noGrp="1"/>
+          </p:cNvSpPr>
+          <p:nvPr>
+            <p:ph type="title"/>
+          </p:nvPr>
+        </p:nvSpPr>
+        <p:spPr>
+          <a:xfrm>
+            <a:off x="539952" y="526396"/>
+            <a:ext cx="9000720" cy="429348"/>
+          </a:xfrm>
+        </p:spPr>
+        <p:txBody>
+          <a:bodyPr/>
+          <a:lstStyle/>
+          <a:p>
+            <a:r>
+              <a:rPr lang="en-US" dirty="0">
+                <a:solidFill>
+                  <a:schemeClr val="tx1"/>
+                </a:solidFill>
+              </a:rPr>
+              <a:t>Another Example Model </a:t>
+            </a:r>
+          </a:p>
+        </p:txBody>
+      </p:sp>
+      <p:sp>
+        <p:nvSpPr>
+          <p:cNvPr id="3" name="Subtitle 2">
+            <a:extLst>
+              <a:ext uri="{FF2B5EF4-FFF2-40B4-BE49-F238E27FC236}">
+                <a16:creationId xmlns:a16="http://schemas.microsoft.com/office/drawing/2014/main" id="{99655AE4-AB4D-3A24-04BD-84A12AFAC48A}"/>
+              </a:ext>
+            </a:extLst>
+          </p:cNvPr>
+          <p:cNvSpPr>
+            <a:spLocks noGrp="1"/>
+          </p:cNvSpPr>
+          <p:nvPr>
+            <p:ph type="subTitle"/>
+          </p:nvPr>
+        </p:nvSpPr>
+        <p:spPr>
+          <a:xfrm>
+            <a:off x="359952" y="1212919"/>
+            <a:ext cx="9360720" cy="4457631"/>
+          </a:xfrm>
+        </p:spPr>
+        <p:txBody>
+          <a:bodyPr/>
+          <a:lstStyle/>
+          <a:p>
+            <a:r>
+              <a:rPr lang="en-US" sz="2000" dirty="0">
+                <a:solidFill>
+                  <a:schemeClr val="tx1"/>
+                </a:solidFill>
+              </a:rPr>
+              <a:t>=== Vehicle Valuation Prediction ===</a:t>
+            </a:r>
+          </a:p>
+          <a:p>
+            <a:r>
+              <a:rPr lang="en-US" sz="2000" dirty="0">
+                <a:solidFill>
+                  <a:schemeClr val="tx1"/>
+                </a:solidFill>
+              </a:rPr>
+              <a:t>Input Vehicle: Toyota  Tacoma</a:t>
+            </a:r>
+          </a:p>
+          <a:p>
+            <a:r>
+              <a:rPr lang="en-US" sz="2000" dirty="0">
+                <a:solidFill>
+                  <a:schemeClr val="tx1"/>
+                </a:solidFill>
+              </a:rPr>
+              <a:t>State: UT | Age: 13.0 years | Odometer: 200,000.0 miles | Condition: 15.0</a:t>
+            </a:r>
+          </a:p>
+          <a:p>
+            <a:r>
+              <a:rPr lang="en-US" sz="2000" dirty="0">
+                <a:solidFill>
+                  <a:schemeClr val="tx1"/>
+                </a:solidFill>
+              </a:rPr>
+              <a:t>Canonical Model Representation: </a:t>
+            </a:r>
+            <a:r>
+              <a:rPr lang="en-US" sz="2000" dirty="0" err="1">
+                <a:solidFill>
+                  <a:schemeClr val="tx1"/>
+                </a:solidFill>
+              </a:rPr>
+              <a:t>toyota_Other</a:t>
+            </a:r>
+            <a:endParaRPr lang="en-US" sz="2000" dirty="0">
+              <a:solidFill>
+                <a:schemeClr val="tx1"/>
+              </a:solidFill>
+            </a:endParaRPr>
+          </a:p>
+          <a:p>
+            <a:r>
+              <a:rPr lang="en-US" sz="2000" dirty="0">
+                <a:solidFill>
+                  <a:schemeClr val="tx1"/>
+                </a:solidFill>
+              </a:rPr>
+              <a:t>------------------------------------</a:t>
+            </a:r>
+          </a:p>
+          <a:p>
+            <a:r>
+              <a:rPr lang="en-US" sz="2000" dirty="0">
+                <a:solidFill>
+                  <a:schemeClr val="tx1"/>
+                </a:solidFill>
+              </a:rPr>
+              <a:t>Predicted Log Selling Price:     7.8247</a:t>
+            </a:r>
+          </a:p>
+          <a:p>
+            <a:r>
+              <a:rPr lang="en-US" sz="2000" dirty="0">
+                <a:solidFill>
+                  <a:schemeClr val="tx1"/>
+                </a:solidFill>
+              </a:rPr>
+              <a:t>Predicted Median Value (naive):  $2,501.65</a:t>
+            </a:r>
+          </a:p>
+          <a:p>
+            <a:r>
+              <a:rPr lang="en-US" sz="2000" dirty="0">
+                <a:solidFill>
+                  <a:schemeClr val="tx1"/>
+                </a:solidFill>
+              </a:rPr>
+              <a:t>Predicted Expected Value (mean): $2,810.73</a:t>
+            </a:r>
+          </a:p>
+          <a:p>
+            <a:r>
+              <a:rPr lang="en-US" sz="2000" dirty="0">
+                <a:solidFill>
+                  <a:schemeClr val="tx1"/>
+                </a:solidFill>
+              </a:rPr>
+              <a:t>Predicted for sale in: UT</a:t>
+            </a:r>
+          </a:p>
+          <a:p>
+            <a:r>
+              <a:rPr lang="en-US" sz="2000" dirty="0">
+                <a:solidFill>
+                  <a:schemeClr val="tx1"/>
+                </a:solidFill>
+              </a:rPr>
+              <a:t>Trade-in offer for 10-15% profit: $2,389.12 to $2,529.66</a:t>
+            </a:r>
+          </a:p>
+          <a:p>
+            <a:r>
+              <a:rPr lang="en-US" sz="2000" dirty="0">
+                <a:solidFill>
+                  <a:schemeClr val="tx1"/>
+                </a:solidFill>
+              </a:rPr>
+              <a:t>====================================</a:t>
+            </a:r>
+          </a:p>
+        </p:txBody>
+      </p:sp>
+    </p:spTree>
+    <p:extLst>
+      <p:ext uri="{BB962C8B-B14F-4D97-AF65-F5344CB8AC3E}">
+        <p14:creationId xmlns:p14="http://schemas.microsoft.com/office/powerpoint/2010/main" val="1830482335"/>
+      </p:ext>
+    </p:extLst>
+  </p:cSld>
+  <p:clrMapOvr>
+    <a:masterClrMapping/>
+  </p:clrMapOvr>
+</p:sld>
+</file>
+
+<file path=ppt/slides/slide14.xml><?xml version="1.0" encoding="utf-8"?>
 <p:sld xmlns:a="http://schemas.openxmlformats.org/drawingml/2006/main" xmlns:r="http://schemas.openxmlformats.org/officeDocument/2006/relationships" xmlns:p="http://schemas.openxmlformats.org/presentationml/2006/main">
   <p:cSld>
     <p:spTree>
@@ -6300,7 +6582,7 @@
 </p:sld>
 </file>
 
-<file path=ppt/slides/slide13.xml><?xml version="1.0" encoding="utf-8"?>
+<file path=ppt/slides/slide15.xml><?xml version="1.0" encoding="utf-8"?>
 <p:sld xmlns:a="http://schemas.openxmlformats.org/drawingml/2006/main" xmlns:r="http://schemas.openxmlformats.org/officeDocument/2006/relationships" xmlns:p="http://schemas.openxmlformats.org/presentationml/2006/main">
   <p:cSld>
     <p:spTree>
@@ -6477,7 +6759,7 @@
 </p:sld>
 </file>
 
-<file path=ppt/slides/slide14.xml><?xml version="1.0" encoding="utf-8"?>
+<file path=ppt/slides/slide16.xml><?xml version="1.0" encoding="utf-8"?>
 <p:sld xmlns:a="http://schemas.openxmlformats.org/drawingml/2006/main" xmlns:r="http://schemas.openxmlformats.org/officeDocument/2006/relationships" xmlns:p="http://schemas.openxmlformats.org/presentationml/2006/main">
   <p:cSld>
     <p:spTree>
@@ -6563,7 +6845,7 @@
 </p:sld>
 </file>
 
-<file path=ppt/slides/slide15.xml><?xml version="1.0" encoding="utf-8"?>
+<file path=ppt/slides/slide17.xml><?xml version="1.0" encoding="utf-8"?>
 <p:sld xmlns:a="http://schemas.openxmlformats.org/drawingml/2006/main" xmlns:r="http://schemas.openxmlformats.org/officeDocument/2006/relationships" xmlns:p="http://schemas.openxmlformats.org/presentationml/2006/main">
   <p:cSld>
     <p:spTree>
@@ -6649,7 +6931,7 @@
 </p:sld>
 </file>
 
-<file path=ppt/slides/slide16.xml><?xml version="1.0" encoding="utf-8"?>
+<file path=ppt/slides/slide18.xml><?xml version="1.0" encoding="utf-8"?>
 <p:sld xmlns:a="http://schemas.openxmlformats.org/drawingml/2006/main" xmlns:r="http://schemas.openxmlformats.org/officeDocument/2006/relationships" xmlns:p="http://schemas.openxmlformats.org/presentationml/2006/main">
   <p:cSld>
     <p:spTree>
@@ -6752,7 +7034,7 @@
         </p:spPr>
         <p:txBody>
           <a:bodyPr lIns="0" tIns="0" rIns="0" bIns="0" anchor="t">
-            <a:normAutofit fontScale="85000" lnSpcReduction="9999"/>
+            <a:normAutofit fontScale="85000" lnSpcReduction="19999"/>
           </a:bodyPr>
           <a:lstStyle/>
           <a:p>
@@ -7094,7 +7376,7 @@
         </p:spPr>
         <p:txBody>
           <a:bodyPr lIns="0" tIns="0" rIns="0" bIns="0" anchor="t">
-            <a:normAutofit fontScale="85000" lnSpcReduction="9999"/>
+            <a:normAutofit fontScale="77500" lnSpcReduction="20000"/>
           </a:bodyPr>
           <a:lstStyle/>
           <a:p>
@@ -7657,7 +7939,7 @@
         </p:spPr>
         <p:txBody>
           <a:bodyPr lIns="0" tIns="0" rIns="0" bIns="0" anchor="t">
-            <a:normAutofit fontScale="55000" lnSpcReduction="19999"/>
+            <a:normAutofit fontScale="47500" lnSpcReduction="20000"/>
           </a:bodyPr>
           <a:lstStyle/>
           <a:p>

</xml_diff>

<commit_message>
removed temporary file. Updated graphics in presentation.
</commit_message>
<xml_diff>
--- a/presentations/project1_presentation.pptx
+++ b/presentations/project1_presentation.pptx
@@ -642,8 +642,8 @@
         </p:nvSpPr>
         <p:spPr>
           <a:xfrm>
-            <a:off x="870120" y="1257480"/>
-            <a:ext cx="6032160" cy="3393720"/>
+            <a:off x="869950" y="1257300"/>
+            <a:ext cx="6032500" cy="3394075"/>
           </a:xfrm>
           <a:prstGeom prst="rect">
             <a:avLst/>
@@ -5586,7 +5586,7 @@
         <p:spPr>
           <a:xfrm>
             <a:off x="504000" y="394560"/>
-            <a:ext cx="9071280" cy="609120"/>
+            <a:ext cx="4453011" cy="609120"/>
           </a:xfrm>
           <a:prstGeom prst="rect">
             <a:avLst/>
@@ -5612,7 +5612,7 @@
               </a:tabLst>
             </a:pPr>
             <a:r>
-              <a:rPr lang="en-US" sz="4400" b="0" u="none" strike="noStrike">
+              <a:rPr lang="en-US" sz="4400" b="0" u="none" strike="noStrike" dirty="0">
                 <a:solidFill>
                   <a:srgbClr val="000000"/>
                 </a:solidFill>
@@ -5623,7 +5623,7 @@
               </a:rPr>
               <a:t>Model Predictors</a:t>
             </a:r>
-            <a:endParaRPr lang="en-US" sz="4400" b="0" u="none" strike="noStrike">
+            <a:endParaRPr lang="en-US" sz="4400" b="0" u="none" strike="noStrike" dirty="0">
               <a:solidFill>
                 <a:srgbClr val="DD4100"/>
               </a:solidFill>
@@ -5636,26 +5636,38 @@
       </p:sp>
       <p:pic>
         <p:nvPicPr>
-          <p:cNvPr id="58" name="Picture 4"/>
-          <p:cNvPicPr/>
+          <p:cNvPr id="3" name="Picture 2">
+            <a:extLst>
+              <a:ext uri="{FF2B5EF4-FFF2-40B4-BE49-F238E27FC236}">
+                <a16:creationId xmlns:a16="http://schemas.microsoft.com/office/drawing/2014/main" id="{C1170AFF-8640-7F04-236E-6E071DD811B9}"/>
+              </a:ext>
+            </a:extLst>
+          </p:cNvPr>
+          <p:cNvPicPr>
+            <a:picLocks noChangeAspect="1"/>
+          </p:cNvPicPr>
           <p:nvPr/>
         </p:nvPicPr>
         <p:blipFill>
-          <a:blip r:embed="rId2"/>
-          <a:stretch/>
+          <a:blip r:embed="rId2" cstate="print">
+            <a:extLst>
+              <a:ext uri="{28A0092B-C50C-407E-A947-70E740481C1C}">
+                <a14:useLocalDpi xmlns:a14="http://schemas.microsoft.com/office/drawing/2010/main" val="0"/>
+              </a:ext>
+            </a:extLst>
+          </a:blip>
+          <a:stretch>
+            <a:fillRect/>
+          </a:stretch>
         </p:blipFill>
         <p:spPr>
           <a:xfrm>
-            <a:off x="771840" y="930600"/>
-            <a:ext cx="8903160" cy="4963320"/>
+            <a:off x="5040312" y="0"/>
+            <a:ext cx="5040313" cy="5670550"/>
           </a:xfrm>
           <a:prstGeom prst="rect">
             <a:avLst/>
           </a:prstGeom>
-          <a:noFill/>
-          <a:ln w="0">
-            <a:noFill/>
-          </a:ln>
         </p:spPr>
       </p:pic>
     </p:spTree>
@@ -5715,7 +5727,7 @@
                   <a:schemeClr val="tx1"/>
                 </a:solidFill>
               </a:rPr>
-              <a:t>Example model output</a:t>
+              <a:t>Example model output (Derrik’s truck)</a:t>
             </a:r>
           </a:p>
         </p:txBody>
@@ -5738,16 +5750,20 @@
         </p:nvSpPr>
         <p:spPr>
           <a:xfrm>
-            <a:off x="360000" y="955744"/>
-            <a:ext cx="9360720" cy="4879339"/>
+            <a:off x="360000" y="1600806"/>
+            <a:ext cx="9360720" cy="3656386"/>
           </a:xfrm>
         </p:spPr>
         <p:txBody>
           <a:bodyPr/>
           <a:lstStyle/>
           <a:p>
-            <a:r>
-              <a:rPr lang="en-US" sz="2000" dirty="0">
+            <a:pPr marL="342900" indent="-342900" algn="l">
+              <a:buFont typeface="Arial" panose="020B0604020202020204" pitchFamily="34" charset="0"/>
+              <a:buChar char="•"/>
+            </a:pPr>
+            <a:r>
+              <a:rPr lang="en-US" sz="2400" dirty="0">
                 <a:solidFill>
                   <a:schemeClr val="tx1"/>
                 </a:solidFill>
@@ -5756,8 +5772,12 @@
             </a:r>
           </a:p>
           <a:p>
-            <a:r>
-              <a:rPr lang="en-US" sz="2000" dirty="0">
+            <a:pPr marL="342900" indent="-342900" algn="l">
+              <a:buFont typeface="Arial" panose="020B0604020202020204" pitchFamily="34" charset="0"/>
+              <a:buChar char="•"/>
+            </a:pPr>
+            <a:r>
+              <a:rPr lang="en-US" sz="2400" dirty="0">
                 <a:solidFill>
                   <a:schemeClr val="tx1"/>
                 </a:solidFill>
@@ -5766,8 +5786,12 @@
             </a:r>
           </a:p>
           <a:p>
-            <a:r>
-              <a:rPr lang="en-US" sz="2000" dirty="0">
+            <a:pPr marL="342900" indent="-342900" algn="l">
+              <a:buFont typeface="Arial" panose="020B0604020202020204" pitchFamily="34" charset="0"/>
+              <a:buChar char="•"/>
+            </a:pPr>
+            <a:r>
+              <a:rPr lang="en-US" sz="2400" dirty="0">
                 <a:solidFill>
                   <a:schemeClr val="tx1"/>
                 </a:solidFill>
@@ -5776,8 +5800,12 @@
             </a:r>
           </a:p>
           <a:p>
-            <a:r>
-              <a:rPr lang="en-US" sz="2000" dirty="0">
+            <a:pPr marL="342900" indent="-342900" algn="l">
+              <a:buFont typeface="Arial" panose="020B0604020202020204" pitchFamily="34" charset="0"/>
+              <a:buChar char="•"/>
+            </a:pPr>
+            <a:r>
+              <a:rPr lang="en-US" sz="2400" dirty="0">
                 <a:solidFill>
                   <a:schemeClr val="tx1"/>
                 </a:solidFill>
@@ -5786,8 +5814,12 @@
             </a:r>
           </a:p>
           <a:p>
-            <a:r>
-              <a:rPr lang="en-US" sz="2000" dirty="0">
+            <a:pPr marL="342900" indent="-342900" algn="l">
+              <a:buFont typeface="Arial" panose="020B0604020202020204" pitchFamily="34" charset="0"/>
+              <a:buChar char="•"/>
+            </a:pPr>
+            <a:r>
+              <a:rPr lang="en-US" sz="2400" dirty="0">
                 <a:solidFill>
                   <a:schemeClr val="tx1"/>
                 </a:solidFill>
@@ -5796,8 +5828,12 @@
             </a:r>
           </a:p>
           <a:p>
-            <a:r>
-              <a:rPr lang="en-US" sz="2000" dirty="0">
+            <a:pPr marL="342900" indent="-342900" algn="l">
+              <a:buFont typeface="Arial" panose="020B0604020202020204" pitchFamily="34" charset="0"/>
+              <a:buChar char="•"/>
+            </a:pPr>
+            <a:r>
+              <a:rPr lang="en-US" sz="2400" dirty="0">
                 <a:solidFill>
                   <a:schemeClr val="tx1"/>
                 </a:solidFill>
@@ -5806,8 +5842,12 @@
             </a:r>
           </a:p>
           <a:p>
-            <a:r>
-              <a:rPr lang="en-US" sz="2000" dirty="0">
+            <a:pPr marL="342900" indent="-342900" algn="l">
+              <a:buFont typeface="Arial" panose="020B0604020202020204" pitchFamily="34" charset="0"/>
+              <a:buChar char="•"/>
+            </a:pPr>
+            <a:r>
+              <a:rPr lang="en-US" sz="2400" dirty="0">
                 <a:solidFill>
                   <a:schemeClr val="tx1"/>
                 </a:solidFill>
@@ -5816,8 +5856,12 @@
             </a:r>
           </a:p>
           <a:p>
-            <a:r>
-              <a:rPr lang="en-US" sz="2000" dirty="0">
+            <a:pPr marL="342900" indent="-342900" algn="l">
+              <a:buFont typeface="Arial" panose="020B0604020202020204" pitchFamily="34" charset="0"/>
+              <a:buChar char="•"/>
+            </a:pPr>
+            <a:r>
+              <a:rPr lang="en-US" sz="2400" dirty="0">
                 <a:solidFill>
                   <a:schemeClr val="tx1"/>
                 </a:solidFill>
@@ -5826,8 +5870,12 @@
             </a:r>
           </a:p>
           <a:p>
-            <a:r>
-              <a:rPr lang="en-US" sz="2000" dirty="0">
+            <a:pPr marL="342900" indent="-342900" algn="l">
+              <a:buFont typeface="Arial" panose="020B0604020202020204" pitchFamily="34" charset="0"/>
+              <a:buChar char="•"/>
+            </a:pPr>
+            <a:r>
+              <a:rPr lang="en-US" sz="2400" dirty="0">
                 <a:solidFill>
                   <a:schemeClr val="tx1"/>
                 </a:solidFill>
@@ -5836,8 +5884,12 @@
             </a:r>
           </a:p>
           <a:p>
-            <a:r>
-              <a:rPr lang="en-US" sz="2000" dirty="0">
+            <a:pPr marL="342900" indent="-342900" algn="l">
+              <a:buFont typeface="Arial" panose="020B0604020202020204" pitchFamily="34" charset="0"/>
+              <a:buChar char="•"/>
+            </a:pPr>
+            <a:r>
+              <a:rPr lang="en-US" sz="2400" dirty="0">
                 <a:solidFill>
                   <a:schemeClr val="tx1"/>
                 </a:solidFill>
@@ -5846,8 +5898,12 @@
             </a:r>
           </a:p>
           <a:p>
-            <a:r>
-              <a:rPr lang="en-US" sz="2000" dirty="0">
+            <a:pPr marL="342900" indent="-342900" algn="l">
+              <a:buFont typeface="Arial" panose="020B0604020202020204" pitchFamily="34" charset="0"/>
+              <a:buChar char="•"/>
+            </a:pPr>
+            <a:r>
+              <a:rPr lang="en-US" sz="2400" dirty="0">
                 <a:solidFill>
                   <a:schemeClr val="tx1"/>
                 </a:solidFill>
@@ -5942,16 +5998,20 @@
         </p:nvSpPr>
         <p:spPr>
           <a:xfrm>
-            <a:off x="359952" y="1083644"/>
-            <a:ext cx="8568895" cy="4457631"/>
+            <a:off x="359952" y="1317812"/>
+            <a:ext cx="8568895" cy="4132729"/>
           </a:xfrm>
         </p:spPr>
         <p:txBody>
           <a:bodyPr/>
           <a:lstStyle/>
           <a:p>
-            <a:r>
-              <a:rPr lang="en-US" sz="2000" dirty="0">
+            <a:pPr marL="342900" indent="-342900" algn="l">
+              <a:buFont typeface="Arial" panose="020B0604020202020204" pitchFamily="34" charset="0"/>
+              <a:buChar char="•"/>
+            </a:pPr>
+            <a:r>
+              <a:rPr lang="en-US" sz="2400" dirty="0">
                 <a:solidFill>
                   <a:schemeClr val="tx1"/>
                 </a:solidFill>
@@ -5960,8 +6020,12 @@
             </a:r>
           </a:p>
           <a:p>
-            <a:r>
-              <a:rPr lang="en-US" sz="2000" dirty="0">
+            <a:pPr marL="342900" indent="-342900" algn="l">
+              <a:buFont typeface="Arial" panose="020B0604020202020204" pitchFamily="34" charset="0"/>
+              <a:buChar char="•"/>
+            </a:pPr>
+            <a:r>
+              <a:rPr lang="en-US" sz="2400" dirty="0">
                 <a:solidFill>
                   <a:schemeClr val="tx1"/>
                 </a:solidFill>
@@ -5970,8 +6034,12 @@
             </a:r>
           </a:p>
           <a:p>
-            <a:r>
-              <a:rPr lang="en-US" sz="2000" dirty="0">
+            <a:pPr marL="342900" indent="-342900" algn="l">
+              <a:buFont typeface="Arial" panose="020B0604020202020204" pitchFamily="34" charset="0"/>
+              <a:buChar char="•"/>
+            </a:pPr>
+            <a:r>
+              <a:rPr lang="en-US" sz="2400" dirty="0">
                 <a:solidFill>
                   <a:schemeClr val="tx1"/>
                 </a:solidFill>
@@ -5980,8 +6048,12 @@
             </a:r>
           </a:p>
           <a:p>
-            <a:r>
-              <a:rPr lang="en-US" sz="2000" dirty="0">
+            <a:pPr marL="342900" indent="-342900" algn="l">
+              <a:buFont typeface="Arial" panose="020B0604020202020204" pitchFamily="34" charset="0"/>
+              <a:buChar char="•"/>
+            </a:pPr>
+            <a:r>
+              <a:rPr lang="en-US" sz="2400" dirty="0">
                 <a:solidFill>
                   <a:schemeClr val="tx1"/>
                 </a:solidFill>
@@ -5990,8 +6062,12 @@
             </a:r>
           </a:p>
           <a:p>
-            <a:r>
-              <a:rPr lang="en-US" sz="2000" dirty="0">
+            <a:pPr marL="342900" indent="-342900" algn="l">
+              <a:buFont typeface="Arial" panose="020B0604020202020204" pitchFamily="34" charset="0"/>
+              <a:buChar char="•"/>
+            </a:pPr>
+            <a:r>
+              <a:rPr lang="en-US" sz="2400" dirty="0">
                 <a:solidFill>
                   <a:schemeClr val="tx1"/>
                 </a:solidFill>
@@ -6000,8 +6076,12 @@
             </a:r>
           </a:p>
           <a:p>
-            <a:r>
-              <a:rPr lang="en-US" sz="2000" dirty="0">
+            <a:pPr marL="342900" indent="-342900" algn="l">
+              <a:buFont typeface="Arial" panose="020B0604020202020204" pitchFamily="34" charset="0"/>
+              <a:buChar char="•"/>
+            </a:pPr>
+            <a:r>
+              <a:rPr lang="en-US" sz="2400" dirty="0">
                 <a:solidFill>
                   <a:schemeClr val="tx1"/>
                 </a:solidFill>
@@ -6010,8 +6090,12 @@
             </a:r>
           </a:p>
           <a:p>
-            <a:r>
-              <a:rPr lang="en-US" sz="2000" dirty="0">
+            <a:pPr marL="342900" indent="-342900" algn="l">
+              <a:buFont typeface="Arial" panose="020B0604020202020204" pitchFamily="34" charset="0"/>
+              <a:buChar char="•"/>
+            </a:pPr>
+            <a:r>
+              <a:rPr lang="en-US" sz="2400" dirty="0">
                 <a:solidFill>
                   <a:schemeClr val="tx1"/>
                 </a:solidFill>
@@ -6020,8 +6104,12 @@
             </a:r>
           </a:p>
           <a:p>
-            <a:r>
-              <a:rPr lang="en-US" sz="2000" dirty="0">
+            <a:pPr marL="342900" indent="-342900" algn="l">
+              <a:buFont typeface="Arial" panose="020B0604020202020204" pitchFamily="34" charset="0"/>
+              <a:buChar char="•"/>
+            </a:pPr>
+            <a:r>
+              <a:rPr lang="en-US" sz="2400" dirty="0">
                 <a:solidFill>
                   <a:schemeClr val="tx1"/>
                 </a:solidFill>
@@ -6030,8 +6118,12 @@
             </a:r>
           </a:p>
           <a:p>
-            <a:r>
-              <a:rPr lang="en-US" sz="2000" dirty="0">
+            <a:pPr marL="342900" indent="-342900" algn="l">
+              <a:buFont typeface="Arial" panose="020B0604020202020204" pitchFamily="34" charset="0"/>
+              <a:buChar char="•"/>
+            </a:pPr>
+            <a:r>
+              <a:rPr lang="en-US" sz="2400" dirty="0">
                 <a:solidFill>
                   <a:schemeClr val="tx1"/>
                 </a:solidFill>
@@ -6040,8 +6132,12 @@
             </a:r>
           </a:p>
           <a:p>
-            <a:r>
-              <a:rPr lang="en-US" sz="2000" dirty="0">
+            <a:pPr marL="342900" indent="-342900" algn="l">
+              <a:buFont typeface="Arial" panose="020B0604020202020204" pitchFamily="34" charset="0"/>
+              <a:buChar char="•"/>
+            </a:pPr>
+            <a:r>
+              <a:rPr lang="en-US" sz="2400" dirty="0">
                 <a:solidFill>
                   <a:schemeClr val="tx1"/>
                 </a:solidFill>
@@ -6050,8 +6146,12 @@
             </a:r>
           </a:p>
           <a:p>
-            <a:r>
-              <a:rPr lang="en-US" sz="2000" dirty="0">
+            <a:pPr marL="342900" indent="-342900" algn="l">
+              <a:buFont typeface="Arial" panose="020B0604020202020204" pitchFamily="34" charset="0"/>
+              <a:buChar char="•"/>
+            </a:pPr>
+            <a:r>
+              <a:rPr lang="en-US" sz="2400" dirty="0">
                 <a:solidFill>
                   <a:schemeClr val="tx1"/>
                 </a:solidFill>
@@ -6146,16 +6246,20 @@
         </p:nvSpPr>
         <p:spPr>
           <a:xfrm>
-            <a:off x="359952" y="1212919"/>
-            <a:ext cx="9360720" cy="4457631"/>
+            <a:off x="359952" y="1609771"/>
+            <a:ext cx="9360720" cy="3656386"/>
           </a:xfrm>
         </p:spPr>
         <p:txBody>
           <a:bodyPr/>
           <a:lstStyle/>
           <a:p>
-            <a:r>
-              <a:rPr lang="en-US" sz="2000" dirty="0">
+            <a:pPr marL="342900" indent="-342900" algn="l">
+              <a:buFont typeface="Arial" panose="020B0604020202020204" pitchFamily="34" charset="0"/>
+              <a:buChar char="•"/>
+            </a:pPr>
+            <a:r>
+              <a:rPr lang="en-US" sz="2400" dirty="0">
                 <a:solidFill>
                   <a:schemeClr val="tx1"/>
                 </a:solidFill>
@@ -6164,18 +6268,26 @@
             </a:r>
           </a:p>
           <a:p>
-            <a:r>
-              <a:rPr lang="en-US" sz="2000" dirty="0">
+            <a:pPr marL="342900" indent="-342900" algn="l">
+              <a:buFont typeface="Arial" panose="020B0604020202020204" pitchFamily="34" charset="0"/>
+              <a:buChar char="•"/>
+            </a:pPr>
+            <a:r>
+              <a:rPr lang="en-US" sz="2400" dirty="0">
                 <a:solidFill>
                   <a:schemeClr val="tx1"/>
                 </a:solidFill>
               </a:rPr>
-              <a:t>Input Vehicle: Toyota  Tacoma</a:t>
-            </a:r>
-          </a:p>
-          <a:p>
-            <a:r>
-              <a:rPr lang="en-US" sz="2000" dirty="0">
+              <a:t>Input Vehicle: Toyota Tacoma</a:t>
+            </a:r>
+          </a:p>
+          <a:p>
+            <a:pPr marL="342900" indent="-342900" algn="l">
+              <a:buFont typeface="Arial" panose="020B0604020202020204" pitchFamily="34" charset="0"/>
+              <a:buChar char="•"/>
+            </a:pPr>
+            <a:r>
+              <a:rPr lang="en-US" sz="2400" dirty="0">
                 <a:solidFill>
                   <a:schemeClr val="tx1"/>
                 </a:solidFill>
@@ -6184,8 +6296,12 @@
             </a:r>
           </a:p>
           <a:p>
-            <a:r>
-              <a:rPr lang="en-US" sz="2000" dirty="0">
+            <a:pPr marL="342900" indent="-342900" algn="l">
+              <a:buFont typeface="Arial" panose="020B0604020202020204" pitchFamily="34" charset="0"/>
+              <a:buChar char="•"/>
+            </a:pPr>
+            <a:r>
+              <a:rPr lang="en-US" sz="2400" dirty="0">
                 <a:solidFill>
                   <a:schemeClr val="tx1"/>
                 </a:solidFill>
@@ -6193,22 +6309,26 @@
               <a:t>Canonical Model Representation: </a:t>
             </a:r>
             <a:r>
-              <a:rPr lang="en-US" sz="2000" dirty="0" err="1">
+              <a:rPr lang="en-US" sz="2400" dirty="0" err="1">
                 <a:solidFill>
                   <a:schemeClr val="tx1"/>
                 </a:solidFill>
               </a:rPr>
               <a:t>toyota_Other</a:t>
             </a:r>
-            <a:endParaRPr lang="en-US" sz="2000" dirty="0">
+            <a:endParaRPr lang="en-US" sz="2400" dirty="0">
               <a:solidFill>
                 <a:schemeClr val="tx1"/>
               </a:solidFill>
             </a:endParaRPr>
           </a:p>
           <a:p>
-            <a:r>
-              <a:rPr lang="en-US" sz="2000" dirty="0">
+            <a:pPr marL="342900" indent="-342900" algn="l">
+              <a:buFont typeface="Arial" panose="020B0604020202020204" pitchFamily="34" charset="0"/>
+              <a:buChar char="•"/>
+            </a:pPr>
+            <a:r>
+              <a:rPr lang="en-US" sz="2400" dirty="0">
                 <a:solidFill>
                   <a:schemeClr val="tx1"/>
                 </a:solidFill>
@@ -6217,8 +6337,12 @@
             </a:r>
           </a:p>
           <a:p>
-            <a:r>
-              <a:rPr lang="en-US" sz="2000" dirty="0">
+            <a:pPr marL="342900" indent="-342900" algn="l">
+              <a:buFont typeface="Arial" panose="020B0604020202020204" pitchFamily="34" charset="0"/>
+              <a:buChar char="•"/>
+            </a:pPr>
+            <a:r>
+              <a:rPr lang="en-US" sz="2400" dirty="0">
                 <a:solidFill>
                   <a:schemeClr val="tx1"/>
                 </a:solidFill>
@@ -6227,8 +6351,12 @@
             </a:r>
           </a:p>
           <a:p>
-            <a:r>
-              <a:rPr lang="en-US" sz="2000" dirty="0">
+            <a:pPr marL="342900" indent="-342900" algn="l">
+              <a:buFont typeface="Arial" panose="020B0604020202020204" pitchFamily="34" charset="0"/>
+              <a:buChar char="•"/>
+            </a:pPr>
+            <a:r>
+              <a:rPr lang="en-US" sz="2400" dirty="0">
                 <a:solidFill>
                   <a:schemeClr val="tx1"/>
                 </a:solidFill>
@@ -6237,8 +6365,12 @@
             </a:r>
           </a:p>
           <a:p>
-            <a:r>
-              <a:rPr lang="en-US" sz="2000" dirty="0">
+            <a:pPr marL="342900" indent="-342900" algn="l">
+              <a:buFont typeface="Arial" panose="020B0604020202020204" pitchFamily="34" charset="0"/>
+              <a:buChar char="•"/>
+            </a:pPr>
+            <a:r>
+              <a:rPr lang="en-US" sz="2400" dirty="0">
                 <a:solidFill>
                   <a:schemeClr val="tx1"/>
                 </a:solidFill>
@@ -6247,8 +6379,12 @@
             </a:r>
           </a:p>
           <a:p>
-            <a:r>
-              <a:rPr lang="en-US" sz="2000" dirty="0">
+            <a:pPr marL="342900" indent="-342900" algn="l">
+              <a:buFont typeface="Arial" panose="020B0604020202020204" pitchFamily="34" charset="0"/>
+              <a:buChar char="•"/>
+            </a:pPr>
+            <a:r>
+              <a:rPr lang="en-US" sz="2400" dirty="0">
                 <a:solidFill>
                   <a:schemeClr val="tx1"/>
                 </a:solidFill>
@@ -6257,8 +6393,12 @@
             </a:r>
           </a:p>
           <a:p>
-            <a:r>
-              <a:rPr lang="en-US" sz="2000" dirty="0">
+            <a:pPr marL="342900" indent="-342900" algn="l">
+              <a:buFont typeface="Arial" panose="020B0604020202020204" pitchFamily="34" charset="0"/>
+              <a:buChar char="•"/>
+            </a:pPr>
+            <a:r>
+              <a:rPr lang="en-US" sz="2400" dirty="0">
                 <a:solidFill>
                   <a:schemeClr val="tx1"/>
                 </a:solidFill>
@@ -6267,8 +6407,12 @@
             </a:r>
           </a:p>
           <a:p>
-            <a:r>
-              <a:rPr lang="en-US" sz="2000" dirty="0">
+            <a:pPr marL="342900" indent="-342900" algn="l">
+              <a:buFont typeface="Arial" panose="020B0604020202020204" pitchFamily="34" charset="0"/>
+              <a:buChar char="•"/>
+            </a:pPr>
+            <a:r>
+              <a:rPr lang="en-US" sz="2400" dirty="0">
                 <a:solidFill>
                   <a:schemeClr val="tx1"/>
                 </a:solidFill>
@@ -9271,26 +9415,38 @@
       </p:pic>
       <p:pic>
         <p:nvPicPr>
-          <p:cNvPr id="50" name="Picture 8"/>
-          <p:cNvPicPr/>
+          <p:cNvPr id="3" name="Picture 2">
+            <a:extLst>
+              <a:ext uri="{FF2B5EF4-FFF2-40B4-BE49-F238E27FC236}">
+                <a16:creationId xmlns:a16="http://schemas.microsoft.com/office/drawing/2014/main" id="{43DF680F-E5F3-B34A-33AD-DCF13C97591D}"/>
+              </a:ext>
+            </a:extLst>
+          </p:cNvPr>
+          <p:cNvPicPr>
+            <a:picLocks noChangeAspect="1"/>
+          </p:cNvPicPr>
           <p:nvPr/>
         </p:nvPicPr>
         <p:blipFill>
-          <a:blip r:embed="rId4"/>
-          <a:stretch/>
+          <a:blip r:embed="rId4">
+            <a:extLst>
+              <a:ext uri="{28A0092B-C50C-407E-A947-70E740481C1C}">
+                <a14:useLocalDpi xmlns:a14="http://schemas.microsoft.com/office/drawing/2010/main" val="0"/>
+              </a:ext>
+            </a:extLst>
+          </a:blip>
+          <a:stretch>
+            <a:fillRect/>
+          </a:stretch>
         </p:blipFill>
         <p:spPr>
           <a:xfrm>
-            <a:off x="4327920" y="1467000"/>
-            <a:ext cx="5408280" cy="3244680"/>
+            <a:off x="4319101" y="1424520"/>
+            <a:ext cx="5479200" cy="3287520"/>
           </a:xfrm>
           <a:prstGeom prst="rect">
             <a:avLst/>
           </a:prstGeom>
-          <a:noFill/>
-          <a:ln w="0">
-            <a:noFill/>
-          </a:ln>
         </p:spPr>
       </p:pic>
     </p:spTree>
@@ -9381,26 +9537,38 @@
       </p:sp>
       <p:pic>
         <p:nvPicPr>
-          <p:cNvPr id="52" name="Picture 8"/>
-          <p:cNvPicPr/>
+          <p:cNvPr id="3" name="Picture 2">
+            <a:extLst>
+              <a:ext uri="{FF2B5EF4-FFF2-40B4-BE49-F238E27FC236}">
+                <a16:creationId xmlns:a16="http://schemas.microsoft.com/office/drawing/2014/main" id="{D22A61F5-6960-C4F5-5640-C4CE42340BAE}"/>
+              </a:ext>
+            </a:extLst>
+          </p:cNvPr>
+          <p:cNvPicPr>
+            <a:picLocks noChangeAspect="1"/>
+          </p:cNvPicPr>
           <p:nvPr/>
         </p:nvPicPr>
         <p:blipFill>
-          <a:blip r:embed="rId2"/>
-          <a:stretch/>
+          <a:blip r:embed="rId2">
+            <a:extLst>
+              <a:ext uri="{28A0092B-C50C-407E-A947-70E740481C1C}">
+                <a14:useLocalDpi xmlns:a14="http://schemas.microsoft.com/office/drawing/2010/main" val="0"/>
+              </a:ext>
+            </a:extLst>
+          </a:blip>
+          <a:stretch>
+            <a:fillRect/>
+          </a:stretch>
         </p:blipFill>
         <p:spPr>
           <a:xfrm>
-            <a:off x="998640" y="1059480"/>
-            <a:ext cx="7511760" cy="4506840"/>
+            <a:off x="1357778" y="1251510"/>
+            <a:ext cx="7365067" cy="4419040"/>
           </a:xfrm>
           <a:prstGeom prst="rect">
             <a:avLst/>
           </a:prstGeom>
-          <a:noFill/>
-          <a:ln w="0">
-            <a:noFill/>
-          </a:ln>
         </p:spPr>
       </p:pic>
     </p:spTree>
@@ -9601,26 +9769,38 @@
       </p:sp>
       <p:pic>
         <p:nvPicPr>
-          <p:cNvPr id="56" name="Picture 6"/>
-          <p:cNvPicPr/>
+          <p:cNvPr id="3" name="Picture 2">
+            <a:extLst>
+              <a:ext uri="{FF2B5EF4-FFF2-40B4-BE49-F238E27FC236}">
+                <a16:creationId xmlns:a16="http://schemas.microsoft.com/office/drawing/2014/main" id="{56A51E16-A419-5A0A-6CAD-3F5C069155EE}"/>
+              </a:ext>
+            </a:extLst>
+          </p:cNvPr>
+          <p:cNvPicPr>
+            <a:picLocks noChangeAspect="1"/>
+          </p:cNvPicPr>
           <p:nvPr/>
         </p:nvPicPr>
         <p:blipFill>
-          <a:blip r:embed="rId2"/>
-          <a:stretch/>
+          <a:blip r:embed="rId2">
+            <a:extLst>
+              <a:ext uri="{28A0092B-C50C-407E-A947-70E740481C1C}">
+                <a14:useLocalDpi xmlns:a14="http://schemas.microsoft.com/office/drawing/2010/main" val="0"/>
+              </a:ext>
+            </a:extLst>
+          </a:blip>
+          <a:stretch>
+            <a:fillRect/>
+          </a:stretch>
         </p:blipFill>
         <p:spPr>
           <a:xfrm>
-            <a:off x="132840" y="977760"/>
-            <a:ext cx="10080360" cy="4479840"/>
+            <a:off x="261724" y="1003680"/>
+            <a:ext cx="9555832" cy="4666870"/>
           </a:xfrm>
           <a:prstGeom prst="rect">
             <a:avLst/>
           </a:prstGeom>
-          <a:noFill/>
-          <a:ln w="0">
-            <a:noFill/>
-          </a:ln>
         </p:spPr>
       </p:pic>
     </p:spTree>

</xml_diff>